<commit_message>
Deck, report, paper: review corrections and author names
Deck: phantom slide separates the controlled 31.7 vs -7.1 dB comparison from the later
47.9 dB fit; Step 5 shows per-budget means and the seed SD (0.02-0.13 dB, from
runs/param_inversion_3d); validation adds the LoG baseline (16-18 of 29) and drops the
unlabelled repeatability card; image percentages labelled as 2D Cellpose whole-frame
scores; 12 frames from 2 embryos stated; cliff slide scoped to C. elegans/LoG and the
K >= 1,000 PSNR range; conclusion no longer says a codec is always as good or better;
next steps separate lossless from noise-bounded coding and drop an unverified B3D ratio.
Report: same corrections, nuclei-kept caveat. Authors: Akim Al-Makhdar; Matr.-Nr. 5301662.

Co-Authored-By: Claude Opus 5.5 <noreply@anthropic.com>
</commit_message>
<xml_diff>
--- a/Gaussian_Blobs_Microscopy_v3.pptx
+++ b/Gaussian_Blobs_Microscopy_v3.pptx
@@ -126,14 +126,14 @@
   <p:extLst>
     <p:ext uri="{521415D9-36F7-43E2-AB2F-B90AF26B5E84}">
       <p14:sectionLst xmlns:p14="http://schemas.microsoft.com/office/powerpoint/2010/main">
-        <p14:section name="Problem and data" id="{11d47e98-1aea-dc8d-4605-6e7523f19562}">
+        <p14:section name="Problem and data" id="{f0cb90bf-5370-dd24-6bd1-a6a499ffaea1}">
           <p14:sldIdLst>
             <p14:sldId id="256"/>
             <p14:sldId id="257"/>
             <p14:sldId id="258"/>
           </p14:sldIdLst>
         </p14:section>
-        <p14:section name="Simple setup and changes" id="{20c4a4f5-636f-974d-d750-c953526ffaec}">
+        <p14:section name="Simple setup and changes" id="{955a83b3-7c75-e644-26e6-77322385f96f}">
           <p14:sldIdLst>
             <p14:sldId id="259"/>
             <p14:sldId id="260"/>
@@ -147,20 +147,20 @@
             <p14:sldId id="268"/>
           </p14:sldIdLst>
         </p14:section>
-        <p14:section name="Results and validation" id="{7544ffb0-a542-f7b4-ea5c-7fba919547b9}">
+        <p14:section name="Results and validation" id="{d2428e7c-28ba-f775-847e-5c4575903008}">
           <p14:sldIdLst>
             <p14:sldId id="269"/>
             <p14:sldId id="270"/>
           </p14:sldIdLst>
         </p14:section>
-        <p14:section name="State of the art" id="{b06002a7-9664-84cf-0af9-5cf6b1599407}">
+        <p14:section name="State of the art" id="{46c815d5-1349-f594-b4e2-df17eb9553c8}">
           <p14:sldIdLst>
             <p14:sldId id="271"/>
             <p14:sldId id="272"/>
             <p14:sldId id="273"/>
           </p14:sldIdLst>
         </p14:section>
-        <p14:section name="Conclusion" id="{59f75a01-f393-fed4-0e18-603fb614352f}">
+        <p14:section name="Conclusion" id="{272ed676-6756-d3dc-c3e9-13391b3178cc}">
           <p14:sldIdLst>
             <p14:sldId id="274"/>
             <p14:sldId id="275"/>
@@ -244,7 +244,7 @@
               <a:lstStyle/>
               <a:p>
                 <a:pPr>
-                  <a:defRPr b="0" i="0" strike="noStrike" sz="1200" u="none">
+                  <a:defRPr b="0" i="0" strike="noStrike" sz="1300" u="none">
                     <a:solidFill>
                       <a:srgbClr val="15171C"/>
                     </a:solidFill>
@@ -312,7 +312,7 @@
             <a:lstStyle/>
             <a:p>
               <a:pPr>
-                <a:defRPr b="0" i="0" strike="noStrike" sz="1200" u="none">
+                <a:defRPr b="0" i="0" strike="noStrike" sz="1300" u="none">
                   <a:solidFill>
                     <a:srgbClr val="15171C"/>
                   </a:solidFill>
@@ -414,7 +414,7 @@
           <a:lstStyle/>
           <a:p>
             <a:pPr>
-              <a:defRPr sz="1100" b="0" i="0" u="none" strike="noStrike">
+              <a:defRPr sz="1200" b="0" i="0" u="none" strike="noStrike">
                 <a:solidFill>
                   <a:srgbClr val="3A3F4B"/>
                 </a:solidFill>
@@ -521,7 +521,7 @@
               <a:lstStyle/>
               <a:p>
                 <a:pPr>
-                  <a:defRPr b="0" i="0" strike="noStrike" sz="1200" u="none">
+                  <a:defRPr b="0" i="0" strike="noStrike" sz="1300" u="none">
                     <a:solidFill>
                       <a:srgbClr val="15171C"/>
                     </a:solidFill>
@@ -589,7 +589,7 @@
             <a:lstStyle/>
             <a:p>
               <a:pPr>
-                <a:defRPr b="0" i="0" strike="noStrike" sz="1200" u="none">
+                <a:defRPr b="0" i="0" strike="noStrike" sz="1300" u="none">
                   <a:solidFill>
                     <a:srgbClr val="15171C"/>
                   </a:solidFill>
@@ -691,7 +691,7 @@
           <a:lstStyle/>
           <a:p>
             <a:pPr>
-              <a:defRPr sz="1100" b="0" i="0" u="none" strike="noStrike">
+              <a:defRPr sz="1200" b="0" i="0" u="none" strike="noStrike">
                 <a:solidFill>
                   <a:srgbClr val="3A3F4B"/>
                 </a:solidFill>
@@ -755,7 +755,7 @@
                 </a:solidFill>
                 <a:latin typeface="+mn-lt"/>
               </a:rPr>
-              <a:t>Real Tribolium crops: PSNR (dB), axis from 20</a:t>
+              <a:t>Tribolium crops: PSNR (dB), 5 seeds each, axis from 20</a:t>
             </a:r>
           </a:p>
         </c:rich>
@@ -779,26 +779,26 @@
               <c:strCache>
                 <c:ptCount val="1"/>
                 <c:pt idx="0">
-                  <c:v>PSNR (dB)</c:v>
+                  <c:v>50 blobs</c:v>
                 </c:pt>
               </c:strCache>
             </c:strRef>
           </c:tx>
           <c:spPr>
             <a:solidFill>
-              <a:srgbClr val="2A78D6"/>
+              <a:srgbClr val="9CC3EE"/>
             </a:solidFill>
             <a:effectLst/>
           </c:spPr>
           <c:invertIfNegative val="0"/>
           <c:dLbls>
-            <c:numFmt formatCode="0.0" sourceLinked="0"/>
+            <c:numFmt formatCode="#,##0" sourceLinked="0"/>
             <c:txPr>
               <a:bodyPr/>
               <a:lstStyle/>
               <a:p>
                 <a:pPr>
-                  <a:defRPr b="0" i="0" strike="noStrike" sz="1200" u="none">
+                  <a:defRPr b="0" i="0" strike="noStrike" sz="1300" u="none">
                     <a:solidFill>
                       <a:srgbClr val="15171C"/>
                     </a:solidFill>
@@ -808,7 +808,7 @@
               </a:p>
             </c:txPr>
             <c:showLegendKey val="0"/>
-            <c:showVal val="1"/>
+            <c:showVal val="0"/>
             <c:showCatName val="0"/>
             <c:showSerName val="0"/>
             <c:showPercent val="0"/>
@@ -841,26 +841,192 @@
                 <c:formatCode>General</c:formatCode>
                 <c:ptCount val="3"/>
                 <c:pt idx="0">
-                  <c:v>22.31</c:v>
+                  <c:v>21.6</c:v>
+                </c:pt>
+                <c:pt idx="1">
+                  <c:v>25.07</c:v>
+                </c:pt>
+                <c:pt idx="2">
+                  <c:v>25.46</c:v>
+                </c:pt>
+              </c:numCache>
+            </c:numRef>
+          </c:val>
+        </c:ser>
+        <c:ser>
+          <c:idx val="1"/>
+          <c:order val="1"/>
+          <c:tx>
+            <c:strRef>
+              <c:f>Sheet1!$C$1</c:f>
+              <c:strCache>
+                <c:ptCount val="1"/>
+                <c:pt idx="0">
+                  <c:v>100 blobs</c:v>
+                </c:pt>
+              </c:strCache>
+            </c:strRef>
+          </c:tx>
+          <c:spPr>
+            <a:solidFill>
+              <a:srgbClr val="2A78D6"/>
+            </a:solidFill>
+            <a:effectLst/>
+          </c:spPr>
+          <c:invertIfNegative val="0"/>
+          <c:dLbls>
+            <c:numFmt formatCode="#,##0" sourceLinked="0"/>
+            <c:txPr>
+              <a:bodyPr/>
+              <a:lstStyle/>
+              <a:p>
+                <a:pPr>
+                  <a:defRPr b="0" i="0" strike="noStrike" sz="1300" u="none">
+                    <a:solidFill>
+                      <a:srgbClr val="15171C"/>
+                    </a:solidFill>
+                    <a:latin typeface="+mn-lt"/>
+                  </a:defRPr>
+                </a:pPr>
+              </a:p>
+            </c:txPr>
+            <c:showLegendKey val="0"/>
+            <c:showVal val="0"/>
+            <c:showCatName val="0"/>
+            <c:showSerName val="0"/>
+            <c:showPercent val="0"/>
+            <c:showBubbleSize val="0"/>
+            <c:showLeaderLines val="0"/>
+          </c:dLbls>
+          <c:cat>
+            <c:multiLvlStrRef>
+              <c:f>Sheet1!$A$2:$A$4</c:f>
+              <c:multiLvlStrCache>
+                <c:ptCount val="3"/>
+                <c:lvl>
+                  <c:pt idx="0">
+                    <c:v>round</c:v>
+                  </c:pt>
+                  <c:pt idx="1">
+                    <c:v>stretched</c:v>
+                  </c:pt>
+                  <c:pt idx="2">
+                    <c:v>stretched + rotated</c:v>
+                  </c:pt>
+                </c:lvl>
+              </c:multiLvlStrCache>
+            </c:multiLvlStrRef>
+          </c:cat>
+          <c:val>
+            <c:numRef>
+              <c:f>Sheet1!$C$2:$C$4</c:f>
+              <c:numCache>
+                <c:formatCode>General</c:formatCode>
+                <c:ptCount val="3"/>
+                <c:pt idx="0">
+                  <c:v>22.2</c:v>
                 </c:pt>
                 <c:pt idx="1">
                   <c:v>25.21</c:v>
                 </c:pt>
                 <c:pt idx="2">
-                  <c:v>25.51</c:v>
+                  <c:v>25.54</c:v>
+                </c:pt>
+              </c:numCache>
+            </c:numRef>
+          </c:val>
+        </c:ser>
+        <c:ser>
+          <c:idx val="2"/>
+          <c:order val="2"/>
+          <c:tx>
+            <c:strRef>
+              <c:f>Sheet1!$D$1</c:f>
+              <c:strCache>
+                <c:ptCount val="1"/>
+                <c:pt idx="0">
+                  <c:v>250 blobs</c:v>
+                </c:pt>
+              </c:strCache>
+            </c:strRef>
+          </c:tx>
+          <c:spPr>
+            <a:solidFill>
+              <a:srgbClr val="1D4F8F"/>
+            </a:solidFill>
+            <a:effectLst/>
+          </c:spPr>
+          <c:invertIfNegative val="0"/>
+          <c:dLbls>
+            <c:numFmt formatCode="#,##0" sourceLinked="0"/>
+            <c:txPr>
+              <a:bodyPr/>
+              <a:lstStyle/>
+              <a:p>
+                <a:pPr>
+                  <a:defRPr b="0" i="0" strike="noStrike" sz="1300" u="none">
+                    <a:solidFill>
+                      <a:srgbClr val="15171C"/>
+                    </a:solidFill>
+                    <a:latin typeface="+mn-lt"/>
+                  </a:defRPr>
+                </a:pPr>
+              </a:p>
+            </c:txPr>
+            <c:showLegendKey val="0"/>
+            <c:showVal val="0"/>
+            <c:showCatName val="0"/>
+            <c:showSerName val="0"/>
+            <c:showPercent val="0"/>
+            <c:showBubbleSize val="0"/>
+            <c:showLeaderLines val="0"/>
+          </c:dLbls>
+          <c:cat>
+            <c:multiLvlStrRef>
+              <c:f>Sheet1!$A$2:$A$4</c:f>
+              <c:multiLvlStrCache>
+                <c:ptCount val="3"/>
+                <c:lvl>
+                  <c:pt idx="0">
+                    <c:v>round</c:v>
+                  </c:pt>
+                  <c:pt idx="1">
+                    <c:v>stretched</c:v>
+                  </c:pt>
+                  <c:pt idx="2">
+                    <c:v>stretched + rotated</c:v>
+                  </c:pt>
+                </c:lvl>
+              </c:multiLvlStrCache>
+            </c:multiLvlStrRef>
+          </c:cat>
+          <c:val>
+            <c:numRef>
+              <c:f>Sheet1!$D$2:$D$4</c:f>
+              <c:numCache>
+                <c:formatCode>General</c:formatCode>
+                <c:ptCount val="3"/>
+                <c:pt idx="0">
+                  <c:v>23.14</c:v>
+                </c:pt>
+                <c:pt idx="1">
+                  <c:v>25.34</c:v>
+                </c:pt>
+                <c:pt idx="2">
+                  <c:v>25.52</c:v>
                 </c:pt>
               </c:numCache>
             </c:numRef>
           </c:val>
         </c:ser>
         <c:dLbls>
-          <c:numFmt formatCode="0.0" sourceLinked="0"/>
+          <c:numFmt formatCode="#,##0" sourceLinked="0"/>
           <c:txPr>
             <a:bodyPr/>
             <a:lstStyle/>
             <a:p>
               <a:pPr>
-                <a:defRPr b="0" i="0" strike="noStrike" sz="1200" u="none">
+                <a:defRPr b="0" i="0" strike="noStrike" sz="1300" u="none">
                   <a:solidFill>
                     <a:srgbClr val="15171C"/>
                   </a:solidFill>
@@ -870,7 +1036,7 @@
             </a:p>
           </c:txPr>
           <c:showLegendKey val="0"/>
-          <c:showVal val="1"/>
+          <c:showVal val="0"/>
           <c:showCatName val="0"/>
           <c:showSerName val="0"/>
           <c:showPercent val="0"/>
@@ -908,7 +1074,7 @@
           <a:lstStyle/>
           <a:p>
             <a:pPr>
-              <a:defRPr sz="1200" b="0" i="0" u="none" strike="noStrike">
+              <a:defRPr sz="1300" b="0" i="0" u="none" strike="noStrike">
                 <a:solidFill>
                   <a:srgbClr val="3A3F4B"/>
                 </a:solidFill>
@@ -962,7 +1128,7 @@
           <a:lstStyle/>
           <a:p>
             <a:pPr>
-              <a:defRPr sz="1100" b="0" i="0" u="none" strike="noStrike">
+              <a:defRPr sz="1200" b="0" i="0" u="none" strike="noStrike">
                 <a:solidFill>
                   <a:srgbClr val="3A3F4B"/>
                 </a:solidFill>
@@ -984,6 +1150,23 @@
         <a:effectLst/>
       </c:spPr>
     </c:plotArea>
+    <c:legend>
+      <c:legendPos val="b"/>
+      <c:overlay val="0"/>
+      <c:txPr>
+        <a:bodyPr/>
+        <a:lstStyle/>
+        <a:p>
+          <a:pPr>
+            <a:defRPr sz="1200">
+              <a:latin typeface="+mn-lt"/>
+              <a:cs typeface="+mn-lt"/>
+            </a:defRPr>
+          </a:pPr>
+          <a:endParaRPr lang="en-US"/>
+        </a:p>
+      </c:txPr>
+    </c:legend>
     <c:plotVisOnly val="1"/>
     <c:dispBlanksAs val="span"/>
   </c:chart>
@@ -1069,7 +1252,7 @@
               <a:lstStyle/>
               <a:p>
                 <a:pPr>
-                  <a:defRPr b="0" i="0" strike="noStrike" sz="1200" u="none">
+                  <a:defRPr b="0" i="0" strike="noStrike" sz="1300" u="none">
                     <a:solidFill>
                       <a:srgbClr val="15171C"/>
                     </a:solidFill>
@@ -1146,7 +1329,7 @@
               <a:lstStyle/>
               <a:p>
                 <a:pPr>
-                  <a:defRPr b="0" i="0" strike="noStrike" sz="1200" u="none">
+                  <a:defRPr b="0" i="0" strike="noStrike" sz="1300" u="none">
                     <a:solidFill>
                       <a:srgbClr val="15171C"/>
                     </a:solidFill>
@@ -1202,7 +1385,7 @@
             <a:lstStyle/>
             <a:p>
               <a:pPr>
-                <a:defRPr b="0" i="0" strike="noStrike" sz="1200" u="none">
+                <a:defRPr b="0" i="0" strike="noStrike" sz="1300" u="none">
                   <a:solidFill>
                     <a:srgbClr val="15171C"/>
                   </a:solidFill>
@@ -1250,7 +1433,7 @@
           <a:lstStyle/>
           <a:p>
             <a:pPr>
-              <a:defRPr sz="1200" b="0" i="0" u="none" strike="noStrike">
+              <a:defRPr sz="1300" b="0" i="0" u="none" strike="noStrike">
                 <a:solidFill>
                   <a:srgbClr val="3A3F4B"/>
                 </a:solidFill>
@@ -1304,7 +1487,7 @@
           <a:lstStyle/>
           <a:p>
             <a:pPr>
-              <a:defRPr sz="1100" b="0" i="0" u="none" strike="noStrike">
+              <a:defRPr sz="1200" b="0" i="0" u="none" strike="noStrike">
                 <a:solidFill>
                   <a:srgbClr val="3A3F4B"/>
                 </a:solidFill>
@@ -1433,7 +1616,7 @@
               <a:lstStyle/>
               <a:p>
                 <a:pPr>
-                  <a:defRPr b="0" i="0" strike="noStrike" sz="1200" u="none">
+                  <a:defRPr b="0" i="0" strike="noStrike" sz="1300" u="none">
                     <a:solidFill>
                       <a:srgbClr val="15171C"/>
                     </a:solidFill>
@@ -1526,7 +1709,7 @@
             <a:lstStyle/>
             <a:p>
               <a:pPr>
-                <a:defRPr b="0" i="0" strike="noStrike" sz="1200" u="none">
+                <a:defRPr b="0" i="0" strike="noStrike" sz="1300" u="none">
                   <a:solidFill>
                     <a:srgbClr val="15171C"/>
                   </a:solidFill>
@@ -1603,7 +1786,7 @@
           <a:lstStyle/>
           <a:p>
             <a:pPr>
-              <a:defRPr sz="1200" b="0" i="0" u="none" strike="noStrike">
+              <a:defRPr sz="1300" b="0" i="0" u="none" strike="noStrike">
                 <a:solidFill>
                   <a:srgbClr val="3A3F4B"/>
                 </a:solidFill>
@@ -1657,7 +1840,7 @@
           <a:lstStyle/>
           <a:p>
             <a:pPr>
-              <a:defRPr sz="1100" b="0" i="0" u="none" strike="noStrike">
+              <a:defRPr sz="1200" b="0" i="0" u="none" strike="noStrike">
                 <a:solidFill>
                   <a:srgbClr val="3A3F4B"/>
                 </a:solidFill>
@@ -1721,7 +1904,7 @@
                 </a:solidFill>
                 <a:latin typeface="+mn-lt"/>
               </a:rPr>
-              <a:t>Luxar minus JPEG2000: nuclei kept (points), mean of 12 frames</a:t>
+              <a:t>Luxar minus JPEG2000: nuclei kept (points), mean of 12 frames, 2 embryos</a:t>
             </a:r>
           </a:p>
         </c:rich>
@@ -1764,7 +1947,7 @@
               <a:lstStyle/>
               <a:p>
                 <a:pPr>
-                  <a:defRPr b="0" i="0" strike="noStrike" sz="1200" u="none">
+                  <a:defRPr b="0" i="0" strike="noStrike" sz="1300" u="none">
                     <a:solidFill>
                       <a:srgbClr val="15171C"/>
                     </a:solidFill>
@@ -1853,7 +2036,7 @@
               <a:lstStyle/>
               <a:p>
                 <a:pPr>
-                  <a:defRPr b="0" i="0" strike="noStrike" sz="1200" u="none">
+                  <a:defRPr b="0" i="0" strike="noStrike" sz="1300" u="none">
                     <a:solidFill>
                       <a:srgbClr val="15171C"/>
                     </a:solidFill>
@@ -1921,7 +2104,7 @@
             <a:lstStyle/>
             <a:p>
               <a:pPr>
-                <a:defRPr b="0" i="0" strike="noStrike" sz="1200" u="none">
+                <a:defRPr b="0" i="0" strike="noStrike" sz="1300" u="none">
                   <a:solidFill>
                     <a:srgbClr val="15171C"/>
                   </a:solidFill>
@@ -1969,7 +2152,7 @@
           <a:lstStyle/>
           <a:p>
             <a:pPr>
-              <a:defRPr sz="1200" b="0" i="0" u="none" strike="noStrike">
+              <a:defRPr sz="1300" b="0" i="0" u="none" strike="noStrike">
                 <a:solidFill>
                   <a:srgbClr val="3A3F4B"/>
                 </a:solidFill>
@@ -2023,7 +2206,7 @@
           <a:lstStyle/>
           <a:p>
             <a:pPr>
-              <a:defRPr sz="1100" b="0" i="0" u="none" strike="noStrike">
+              <a:defRPr sz="1200" b="0" i="0" u="none" strike="noStrike">
                 <a:solidFill>
                   <a:srgbClr val="3A3F4B"/>
                 </a:solidFill>
@@ -2569,12 +2752,13 @@
             <a:r>
               <a:rPr lang="en-US" dirty="0"/>
               <a:t>SAY:
-Our first own step was to check Akim's shape result with repeats: the same three blob shapes, each fitted 15 times, with 5 random seeds and 3 blob budgets, on the same kind of real crops. The result holds: 22.3 dB for round blobs, 25.5 for stretched and rotated, and the spread between repeats is small. Most of the gain comes from stretching; rotation adds half a dB. And the blobs did what we expected: their depth-to-width ratio, 0.79, is close to the ratio measured on the real nuclei, 0.73. Real nuclei look stretched in depth partly because the microscope blurs more along that axis.
+Our first own step was to check Akim's shape result with repeats: the same three blob shapes, at 50, 100 and 250 blobs, each with 5 random seeds, on the same kind of real crops. The result holds at every budget: averaged over all 15 fits, 22.3 dB for round blobs and 25.5 for stretched and rotated. Repeats with different seeds differ by at most about a tenth of a dB, far less than the 3 dB effect. Most of the gain comes from stretching; rotation adds about 0.3 dB. And the blobs did what we expected: their depth-to-width ratio, 0.79, is close to the ratio measured on the real nuclei, 0.73. Real nuclei look stretched in depth partly because the microscope blurs more along that axis.
 TERMS ON THIS SLIDE:
 - Round (isotropic) blob: same size in every direction.
 - Stretched (anisotropic, axis-aligned) blob: three independent sizes along x, y and z.
 - Rotation: lets the stretched blob point in any direction.
 - Seed: the random number that decides the starting point of a fit; different seeds test whether a result is luck.
+- SD (standard deviation): the typical distance of single results from their average; here, how much repeats differ.
 IF ASKED:
 - Did this also help finding nuclei? Slightly: nucleus F1 0.745 (round) vs 0.805 (stretched + rotated), significant in a paired test (p = 0.006, 5 seeds).
 - Why does the axis start at 20? To make a 3 dB difference visible; it is stated on the chart.</a:t>
@@ -3045,13 +3229,15 @@
             <a:r>
               <a:rPr lang="en-US" dirty="0"/>
               <a:t>SAY:
-Three checks that the fit does what we think. First, shape: the learned blobs are about as stretched as the real nuclei. Second, the honest test against people's annotations: on Drosophila, among the 100 most confident detections, the fitted blobs contain 14 of 29 hand-marked nuclei, the raw image only 10. So fitting ranks real nuclei higher. Third, fits are repeatable. And the limit: if the plain detector may use all its candidates it finds 26 of 29, more than any fit. So this is better ranking, not a better detector.
+Checks that the fit does what we think. First, shape: the learned blobs are about as stretched as the real nuclei. Second, the honest test against people's annotations: on Drosophila, among the 100 most confident detections, the fitted blobs contain 14 of 29 hand-marked nuclei, the raw image ranked by brightness only 10. So fitting ranks real nuclei higher than brightness does. But third, the stronger baseline: a classic blob filter, LoG, applied to the same raw candidates puts 16 to 18 marked nuclei in the top 100, in seconds and without any fitting. So the fit beats the naive baseline, not the simple strong one. And if the plain detector may use all its candidates it finds 26 of 29, more than any fit. This is better ranking than brightness, not a better detector.
 TERMS ON THIS SLIDE:
 - Top 100 detections: compare methods at the same number of guesses, because only some nuclei are marked and extra detections cannot be judged as wrong.
-- Raw-image detector: the same peak detector run directly on the original data.
-- Repeated fits: the same data fitted three times; for the Luxar fits used later, nuclei kept differed by at most 2.1-3.7 points depending on the detector.
+- Raw brightness: the raw image's candidate peaks ranked simply by how bright they are.
+- LoG blob filter: ranks the same candidates by how well they look like a round blob of nucleus size.
 IF ASKED:
-- How noisy is 14 vs 10? One nucleus is 3.4% of 29; we only call a difference real if it is about 3 nuclei and has the same sign in all seeds (mean of 3 seeds here).</a:t>
+- How noisy is 14 vs 10? One nucleus is 3.4% of 29; we only call a difference real if it is about 3 nuclei and has the same sign in all seeds (mean of 3 seeds here).
+- Why 16-18? 16 with LoG scales fixed in advance (1.5-3 micrometres); 18 with a single 2-micrometre scale chosen after seeing results.
+- Are fits repeatable? Our own fits: seed spread at most 0.13 dB (Step 5). Luxar, used on the next slides: three repeated fits of one frame differed by at most 2.1-3.7 percentage points of nuclei kept, depending on the detector.</a:t>
             </a:r>
             <a:endParaRPr lang="en-US" dirty="0"/>
           </a:p>
@@ -3140,12 +3326,13 @@
             <a:r>
               <a:rPr lang="en-US" dirty="0"/>
               <a:t>SAY:
-Our own fits were better than our naive start, but are they better than what exists? The strongest existing tool is Luxar, from the Royer lab, which fits Gaussian blobs to large microscopy data. We compared Luxar with ordinary image compression, JPEG2000, squeezed to exactly the same number of bytes, on 12 C. elegans frames with almost 3,000 hand-marked nuclei, and asked four different nucleus detectors how many nuclei survive. The pictures show the same region at about 89 times smaller: the codecs keep the texture, Luxar draws smooth blobs.
+Our own fits were better than our naive start, but are they better than what exists? The strongest existing tool is Luxar, from the Royer lab, which fits Gaussian blobs to large microscopy data. We compared Luxar with ordinary image compression, JPEG2000, squeezed to exactly the same number of bytes, on 12 C. elegans frames from two embryos with almost 3,000 hand-marked nuclei, and asked four different nucleus detectors how many nuclei survive. The pictures show the same region at about 89 times smaller: the codecs keep the texture, Luxar draws smooth blobs. The percentages are whole-frame scores from one detector, 2D Cellpose.
 TERMS ON THIS SLIDE:
 - Compression ratio: original size divided by compressed size; 100x means 100 times smaller.
 - Same file size (matched bytes): every Luxar file is compared with a JPEG2000 file of exactly the same size on disk.
 - JPEG2000 / JPEG-XL: standard image compression formats; here each 2D slice of the volume is compressed.
-- Nuclei kept: nuclei found after compression divided by nuclei found in the original by the same detector (1.0 = nothing lost).
+- Nuclei kept: hand-marked nuclei found after compression divided by those found in the original by the same detector. 1.0 means the same number was found, not necessarily the same individual nuclei.
+- Whole-frame score: the percentages under the pictures are for the whole frame with 2D Cellpose; the pictures show only a small region.
 IF ASKED:
 - Why not compare with our own fits? Luxar is faster and better engineered; if blobs are to win anywhere, the strongest blob tool must win.
 - We found a bug in our own first JPEG2000 setup (it compressed the volume along the wrong axes, about 10 dB worse). Fixing it reversed our first conclusion; a test now prevents it.</a:t>
@@ -3243,9 +3430,10 @@
 - Watershed: a classical segmentation that separates touching bright regions, like water filling valleys.
 - Cellpose: a widely used deep-learning model that outlines cells or nuclei. 2D mode works slice by slice and joins slices; 3D mode looks at the volume in three directions at once.
 - Points: percentage points of nuclei kept, e.g. 0.90 vs 0.86 is 4 points.
-- Statistics: each frame counts once; Wilcoxon signed-rank tests over the 12 frames, Holm-corrected for 8 tests. Everything except LoG below 300x is significant (p ≤ 0.01).
+- Statistics: each frame counts once; Wilcoxon signed-rank tests over the 12 frames, Holm-corrected for 8 tests. Everything except LoG below 300x is significant (Holm-corrected p ≤ 0.01). The 12 frames come from only 2 embryos, so they are not 12 independent animals.
 IF ASKED:
 - Is LoG +1.3 real? No: 8 of 12 frames, p = 0.11; it comes from one embryo only.
+- Why frames and not single comparisons? An earlier draft averaged all matched pairs, with bootstrap intervals per pair. Pairs from one frame are not independent, so the final analysis averages per frame first and tests across frames; the numbers here are that final analysis, the same as in the paper.
 - Why does JPEG2000 win at high compression? Below about 3 blobs per nucleus, blob fits lose whole nuclei; wavelet compression degrades gradually.</a:t>
             </a:r>
             <a:endParaRPr lang="en-US" dirty="0"/>
@@ -3335,12 +3523,13 @@
             <a:r>
               <a:rPr lang="en-US" dirty="0"/>
               <a:t>SAY:
-Why do blobs collapse at high compression? Each point is one Luxar fit; the x axis is blobs per hand-marked nucleus. Above about 3 blobs per nucleus almost every nucleus survives; below that, they disappear quickly, on every frame of both embryos. At the same time, PSNR changes very little across these budgets. So if you choose the budget by image quality, you can fall off this cliff without noticing.
+Why do blobs collapse at high compression? Each point is one Luxar fit; the x axis is blobs per hand-marked nucleus. In these C. elegans frames, with the LoG detector, almost every nucleus survives above about 3 blobs per nucleus; below that, they disappear quickly, on every frame of both embryos: the 90% line is crossed between 1.1 and 3.1 blobs per nucleus. For budgets of 1,000 blobs and more, PSNR changes by at most 2.6 dB per frame. So if you choose the budget by image quality, you can fall off this cliff without noticing. Honestly, our advance test of that PSNR claim held on only 4 of the 8 added frames, because on small frames the cliff lies below 1,000 blobs.
 TERMS ON THIS SLIDE:
 - Blobs per nucleus: number of blobs in the fit divided by the number of hand-marked nuclei in that frame.
 - Cliff: a sudden drop instead of a gradual decline.
 - 90% line: the threshold we fixed in advance to define the cliff (we wrote down '≤ 3.5 blobs per nucleus' before running the extra frames).
 IF ASKED:
+- Does the 3-blobs rule hold everywhere? We only tested C. elegans frames with the LoG detector; other data or detectors may cross elsewhere.
 - Why fix thresholds in advance? So we cannot tune the claim to the data afterwards. Two of our advance predictions failed, and we report them as failed.</a:t>
             </a:r>
             <a:endParaRPr lang="en-US" dirty="0"/>
@@ -3430,11 +3619,12 @@
             <a:r>
               <a:rPr lang="en-US" dirty="0"/>
               <a:t>SAY:
-Three take-aways. One: our step-by-step changes made blob fits find nuclei much more reliably. Two: compared with the state of the art at equal file size, blobs are good for viewing but not the right format for measuring; a standard codec keeps the nuclei as well or better. Three: the usual image-quality number cannot decide this; you have to test with the analysis you plan to run.
+Three take-aways. One: our step-by-step changes made blob fits find nuclei more reliably, but on hand-marked nuclei a simple blob filter still ranks them better. Two: compared with the state of the art at the same file size, there is no single winner. Below 300 times, the blobs help 3D Cellpose and hurt the watershed and 2D Cellpose; beyond 300 times JPEG2000 keeps more nuclei for every detector. Three: a format that looks good is not automatically good for measuring, and the usual image-quality number cannot decide this; you have to test with the analysis you plan to run.
 TERMS ON THIS SLIDE:
 - Codec: a compression method (coder-decoder).
 IF ASKED:
-- So was the project a failure? No: we now know where blobs should and should not be trusted, which is what a user needs; and the evaluation method itself is reusable.</a:t>
+- So was the project a failure? No: we now know where blobs should and should not be trusted, which is what a user needs; and the evaluation method itself is reusable.
+- Are blobs useless for measuring? Not in general: with 3D Cellpose they kept more nuclei at moderate compression. But each analysis has to be checked separately.</a:t>
             </a:r>
             <a:endParaRPr lang="en-US" dirty="0"/>
           </a:p>
@@ -3618,14 +3808,15 @@
             <a:r>
               <a:rPr lang="en-US" dirty="0"/>
               <a:t>SAY:
-Following our supervisor's advice, the next step is compression biologists would actually use: lossless storage, or near-lossless where every error stays below the camera noise; video codecs, which exploit the similarity between neighbouring slices and time points; and judging success by whether cells can still be tracked, using the Cell Tracking Challenge's official scores.
+This is a change of direction, agreed with our supervisor after his feedback. So far we asked whether Gaussian blobs can store and show microscopy data; he pointed out that labs store their raw data losslessly and rarely use lossy formats like JPEG. So the next step is compression biologists would actually use. First, lossless storage, which gives about 2 to 4 times; we measured 4.2 times with lossless JPEG-XL on one C. elegans frame. Second, one specific near-lossless approach, noise-bounded coding, where every voxel may change but by less than the camera noise. Third, video codecs, which exploit the similarity between neighbouring slices and time points. And fourth, judging success by whether cells can still be tracked, using the Cell Tracking Challenge's official scores.
 TERMS ON THIS SLIDE:
 - Lossless: the decompressed data is bit-for-bit identical to the original.
-- Near-lossless / noise-bounded: every voxel may change, but by less than the camera's own noise.
+- Near-lossless: small, bounded changes are allowed. Noise-bounded coding is one way to set that bound: below the camera's own noise.
 - Video codec: compression made for movies (e.g. H.265, AV1) that predicts each frame from its neighbours.
 - Tracking: following each cell over time, including divisions.
 IF ASKED:
-- How much do lossless methods give? Typically 2-4x on microscopy (we measured 4.2x with lossless JPEG-XL on C. elegans); noise-bounded methods reach far more on raw camera data (up to ~100x reported for B3D).</a:t>
+- How much do lossless methods give? On our C. elegans frame: lossless JPEG-XL 4.2x, JPEG-LS 2.9x, JPEG2000 lossless 2.7x, Zstandard 2.5x. Noise-bounded coding can go further; how far depends on the camera noise, and we have not measured it on our data yet.
+- Why change direction? The supervisor's feedback: biologists need their measurements to stay valid, and they trust lossless or noise-bounded storage. Gaussian blobs remain interesting for viewing.</a:t>
             </a:r>
             <a:endParaRPr lang="en-US" dirty="0"/>
           </a:p>
@@ -3906,7 +4097,7 @@
             <a:r>
               <a:rPr lang="en-US" dirty="0"/>
               <a:t>SAY:
-Before touching real data we built the simplest possible test: a synthetic volume made of blobs, so we know the right answer. We fit blobs to it by comparing the blob sum with the volume at every voxel. It recovers the phantom almost perfectly, 47.9 dB. We also learned something here: the standard 3D Gaussian splatting renderer, designed for photographs of solid objects, treats blobs as blocking the ones behind them. Our volumes are transparent and glowing, so that rule is wrong; scored that way the same kind of fit collapsed to minus 7 dB. So from here on we compare blobs to voxels directly.
+Before touching real data we built the simplest possible test: a synthetic volume made of blobs, so we know the right answer. We fit blobs to it by comparing the blob sum with the volume at every voxel. We also learned something here: the standard 3D Gaussian splatting renderer, designed for photographs of solid objects, treats blobs as blocking the ones behind them. Our volumes are transparent and glowing, so that rule is wrong. In a controlled test on a small 15-blob phantom, the same fit scored 31.7 dB when compared at the voxels and minus 7.1 dB through the splatting renderer. So from here on we compare blobs to voxels directly. Our final phantom fit, with 2,000 blobs on a 50-blob phantom, reached 47.9 dB, almost perfect; that is a separate, later run.
 TERMS ON THIS SLIDE:
 - Phantom: artificial test data with a known answer.
 - PSNR (peak signal-to-noise ratio), in dB: a number for how close the reconstruction is to the data; higher is better, +3 dB roughly halves the squared error. It says nothing about whether nuclei survive.
@@ -3914,7 +4105,7 @@
 - Alpha-blending (alpha-compositing): the renderer rule that each blob partly hides the blobs behind it. Correct for opaque surfaces, wrong for glowing transparent volumes.
 - Comparing at every voxel (voxel query): evaluate the blob sum at each voxel centre and compare with the data. No camera, no hiding.
 IF ASKED:
-- Why −7.1 dB and 47.9 dB on different phantoms? −7.1 vs 31.7 dB was the controlled comparison on a 15-blob phantom (same fit, two ways of scoring). 47.9 dB is the final phantom fit with 2,000 blobs.</a:t>
+- Why two phantoms? 31.7 vs −7.1 dB is the controlled comparison (same fit, two ways of scoring, 15-blob phantom). 47.9 dB is a later run (2,000 blobs fitted to a 50-blob phantom) and is not part of that comparison.</a:t>
             </a:r>
             <a:endParaRPr lang="en-US" dirty="0"/>
           </a:p>
@@ -5160,7 +5351,7 @@
                   <a:srgbClr val="C9CDD6"/>
                 </a:solidFill>
               </a:rPr>
-              <a:t>Syed Muhammad Asad, Akim</a:t>
+              <a:t>Syed Muhammad Asad, Akim Al-Makhdar</a:t>
             </a:r>
             <a:endParaRPr lang="en-US" sz="1600" dirty="0"/>
           </a:p>
@@ -5335,7 +5526,43 @@
       </p:graphicFrame>
       <p:sp>
         <p:nvSpPr>
-          <p:cNvPr id="4" name="step-card-0"/>
+          <p:cNvPr id="4" name="Text 1"/>
+          <p:cNvSpPr txBox="1"/>
+          <p:nvPr/>
+        </p:nvSpPr>
+        <p:spPr>
+          <a:xfrm>
+            <a:off x="457200" y="4343400"/>
+            <a:ext cx="4754880" cy="274320"/>
+          </a:xfrm>
+          <a:prstGeom prst="rect">
+            <a:avLst/>
+          </a:prstGeom>
+          <a:noFill/>
+          <a:ln/>
+        </p:spPr>
+        <p:txBody>
+          <a:bodyPr wrap="square" lIns="0" tIns="0" rIns="0" bIns="0" rtlCol="0" anchor="t"/>
+          <a:lstStyle/>
+          <a:p>
+            <a:pPr indent="0" marL="0">
+              <a:buNone/>
+            </a:pPr>
+            <a:r>
+              <a:rPr lang="en-US" sz="1200" dirty="0">
+                <a:solidFill>
+                  <a:schemeClr val="accent5"/>
+                </a:solidFill>
+              </a:rPr>
+              <a:t>Seed-to-seed spread (SD) within each bar: 0.02–0.13 dB</a:t>
+            </a:r>
+            <a:endParaRPr lang="en-US" sz="1200" dirty="0"/>
+          </a:p>
+        </p:txBody>
+      </p:sp>
+      <p:sp>
+        <p:nvSpPr>
+          <p:cNvPr id="5" name="step-card-0"/>
           <p:cNvSpPr/>
           <p:nvPr/>
         </p:nvSpPr>
@@ -5362,7 +5589,7 @@
       </p:sp>
       <p:sp>
         <p:nvSpPr>
-          <p:cNvPr id="5" name="Text 2"/>
+          <p:cNvPr id="6" name="Text 3"/>
           <p:cNvSpPr txBox="1"/>
           <p:nvPr/>
         </p:nvSpPr>
@@ -5398,7 +5625,7 @@
       </p:sp>
       <p:sp>
         <p:nvSpPr>
-          <p:cNvPr id="6" name="Text 3"/>
+          <p:cNvPr id="7" name="Text 4"/>
           <p:cNvSpPr txBox="1"/>
           <p:nvPr/>
         </p:nvSpPr>
@@ -5434,7 +5661,7 @@
       </p:sp>
       <p:sp>
         <p:nvSpPr>
-          <p:cNvPr id="7" name="step-card-1"/>
+          <p:cNvPr id="8" name="step-card-1"/>
           <p:cNvSpPr/>
           <p:nvPr/>
         </p:nvSpPr>
@@ -5461,7 +5688,7 @@
       </p:sp>
       <p:sp>
         <p:nvSpPr>
-          <p:cNvPr id="8" name="Text 5"/>
+          <p:cNvPr id="9" name="Text 6"/>
           <p:cNvSpPr txBox="1"/>
           <p:nvPr/>
         </p:nvSpPr>
@@ -5497,7 +5724,7 @@
       </p:sp>
       <p:sp>
         <p:nvSpPr>
-          <p:cNvPr id="9" name="Text 6"/>
+          <p:cNvPr id="10" name="Text 7"/>
           <p:cNvSpPr txBox="1"/>
           <p:nvPr/>
         </p:nvSpPr>
@@ -5533,7 +5760,7 @@
       </p:sp>
       <p:sp>
         <p:nvSpPr>
-          <p:cNvPr id="10" name="step-card-2"/>
+          <p:cNvPr id="11" name="step-card-2"/>
           <p:cNvSpPr/>
           <p:nvPr/>
         </p:nvSpPr>
@@ -5560,7 +5787,7 @@
       </p:sp>
       <p:sp>
         <p:nvSpPr>
-          <p:cNvPr id="11" name="Text 8"/>
+          <p:cNvPr id="12" name="Text 9"/>
           <p:cNvSpPr txBox="1"/>
           <p:nvPr/>
         </p:nvSpPr>
@@ -5596,7 +5823,7 @@
       </p:sp>
       <p:sp>
         <p:nvSpPr>
-          <p:cNvPr id="12" name="Text 9"/>
+          <p:cNvPr id="13" name="Text 10"/>
           <p:cNvSpPr txBox="1"/>
           <p:nvPr/>
         </p:nvSpPr>
@@ -5624,7 +5851,7 @@
                   <a:schemeClr val="tx1"/>
                 </a:solidFill>
               </a:rPr>
-              <a:t>+3.2 dB with small spread; learned blobs are as stretched as real nuclei</a:t>
+              <a:t>+3.2 dB (22.3 → 25.5), seed SD ≤ 0.13 dB; learned blobs as stretched as real nuclei</a:t>
             </a:r>
             <a:endParaRPr lang="en-US" sz="1400" dirty="0"/>
           </a:p>
@@ -10375,7 +10602,7 @@
         <p:spPr>
           <a:xfrm>
             <a:off x="640080" y="2148840"/>
-            <a:ext cx="2240280" cy="1234440"/>
+            <a:ext cx="2240280" cy="1280160"/>
           </a:xfrm>
           <a:prstGeom prst="rect">
             <a:avLst/>
@@ -10477,7 +10704,7 @@
         <p:spPr>
           <a:xfrm>
             <a:off x="3429000" y="2148840"/>
-            <a:ext cx="2240280" cy="1234440"/>
+            <a:ext cx="2240280" cy="1280160"/>
           </a:xfrm>
           <a:prstGeom prst="rect">
             <a:avLst/>
@@ -10498,7 +10725,7 @@
                   <a:schemeClr val="tx2"/>
                 </a:solidFill>
               </a:rPr>
-              <a:t>hand-marked Drosophila nuclei in the top 100 detections: fitted blobs vs raw image</a:t>
+              <a:t>of 29 hand-marked Drosophila nuclei in the top 100 detections: fitted blobs vs raw brightness</a:t>
             </a:r>
             <a:endParaRPr lang="en-US" sz="1500" dirty="0"/>
           </a:p>
@@ -10558,13 +10785,13 @@
             <a:r>
               <a:rPr lang="en-US" sz="3200" b="1" dirty="0">
                 <a:solidFill>
-                  <a:schemeClr val="accent3"/>
+                  <a:schemeClr val="accent4"/>
                 </a:solidFill>
                 <a:latin typeface="Cambria" pitchFamily="34" charset="0"/>
                 <a:ea typeface="Cambria" pitchFamily="34" charset="-122"/>
                 <a:cs typeface="Cambria" pitchFamily="34" charset="-120"/>
               </a:rPr>
-              <a:t>≤ 4%</a:t>
+              <a:t>16–18</a:t>
             </a:r>
             <a:endParaRPr lang="en-US" sz="3200" dirty="0"/>
           </a:p>
@@ -10579,7 +10806,7 @@
         <p:spPr>
           <a:xfrm>
             <a:off x="6217920" y="2148840"/>
-            <a:ext cx="2240280" cy="1234440"/>
+            <a:ext cx="2240280" cy="1280160"/>
           </a:xfrm>
           <a:prstGeom prst="rect">
             <a:avLst/>
@@ -10600,7 +10827,7 @@
                   <a:schemeClr val="tx2"/>
                 </a:solidFill>
               </a:rPr>
-              <a:t>difference in nuclei found between three repeated fits</a:t>
+              <a:t>same top 100, raw candidates ranked by a simple LoG blob filter: better than every fit</a:t>
             </a:r>
             <a:endParaRPr lang="en-US" sz="1500" dirty="0"/>
           </a:p>
@@ -10614,8 +10841,8 @@
         </p:nvSpPr>
         <p:spPr>
           <a:xfrm>
-            <a:off x="457200" y="3840480"/>
-            <a:ext cx="8229600" cy="548640"/>
+            <a:off x="457200" y="3749040"/>
+            <a:ext cx="8229600" cy="640080"/>
           </a:xfrm>
           <a:prstGeom prst="rect">
             <a:avLst/>
@@ -10636,7 +10863,7 @@
                   <a:schemeClr val="tx2"/>
                 </a:solidFill>
               </a:rPr>
-              <a:t>Limit: with all 457 of its candidates the raw-image detector finds 26 of 29, more than any fit.</a:t>
+              <a:t>Fitting ranks nuclei better than brightness, but not better than a simple blob filter. With all 457 candidates the raw detector finds 26 of 29.</a:t>
             </a:r>
             <a:endParaRPr lang="en-US" sz="1500" dirty="0"/>
           </a:p>
@@ -10879,7 +11106,7 @@
         <p:spPr>
           <a:xfrm>
             <a:off x="2532888" y="2880360"/>
-            <a:ext cx="2011680" cy="256032"/>
+            <a:ext cx="2011680" cy="411480"/>
           </a:xfrm>
           <a:prstGeom prst="rect">
             <a:avLst/>
@@ -10901,6 +11128,20 @@
                 </a:solidFill>
               </a:rPr>
               <a:t>100% of nuclei kept</a:t>
+            </a:r>
+            <a:endParaRPr lang="en-US" sz="1200" dirty="0"/>
+          </a:p>
+          <a:p>
+            <a:pPr algn="ctr" indent="0" marL="0">
+              <a:buNone/>
+            </a:pPr>
+            <a:r>
+              <a:rPr lang="en-US" sz="1000" dirty="0">
+                <a:solidFill>
+                  <a:schemeClr val="accent5"/>
+                </a:solidFill>
+              </a:rPr>
+              <a:t>2D Cellpose, whole frame</a:t>
             </a:r>
             <a:endParaRPr lang="en-US" sz="1200" dirty="0"/>
           </a:p>
@@ -10975,7 +11216,7 @@
         <p:spPr>
           <a:xfrm>
             <a:off x="4608576" y="2880360"/>
-            <a:ext cx="2011680" cy="256032"/>
+            <a:ext cx="2011680" cy="411480"/>
           </a:xfrm>
           <a:prstGeom prst="rect">
             <a:avLst/>
@@ -10997,6 +11238,20 @@
                 </a:solidFill>
               </a:rPr>
               <a:t>97% of nuclei kept</a:t>
+            </a:r>
+            <a:endParaRPr lang="en-US" sz="1200" dirty="0"/>
+          </a:p>
+          <a:p>
+            <a:pPr algn="ctr" indent="0" marL="0">
+              <a:buNone/>
+            </a:pPr>
+            <a:r>
+              <a:rPr lang="en-US" sz="1000" dirty="0">
+                <a:solidFill>
+                  <a:schemeClr val="accent5"/>
+                </a:solidFill>
+              </a:rPr>
+              <a:t>2D Cellpose, whole frame</a:t>
             </a:r>
             <a:endParaRPr lang="en-US" sz="1200" dirty="0"/>
           </a:p>
@@ -11071,7 +11326,7 @@
         <p:spPr>
           <a:xfrm>
             <a:off x="6684264" y="2880360"/>
-            <a:ext cx="2011680" cy="256032"/>
+            <a:ext cx="2011680" cy="411480"/>
           </a:xfrm>
           <a:prstGeom prst="rect">
             <a:avLst/>
@@ -11096,6 +11351,20 @@
             </a:r>
             <a:endParaRPr lang="en-US" sz="1200" dirty="0"/>
           </a:p>
+          <a:p>
+            <a:pPr algn="ctr" indent="0" marL="0">
+              <a:buNone/>
+            </a:pPr>
+            <a:r>
+              <a:rPr lang="en-US" sz="1000" dirty="0">
+                <a:solidFill>
+                  <a:schemeClr val="accent5"/>
+                </a:solidFill>
+              </a:rPr>
+              <a:t>2D Cellpose, whole frame</a:t>
+            </a:r>
+            <a:endParaRPr lang="en-US" sz="1200" dirty="0"/>
+          </a:p>
         </p:txBody>
       </p:sp>
       <p:sp>
@@ -11106,7 +11375,7 @@
         </p:nvSpPr>
         <p:spPr>
           <a:xfrm>
-            <a:off x="457200" y="3291840"/>
+            <a:off x="457200" y="3429000"/>
             <a:ext cx="2606040" cy="1188720"/>
           </a:xfrm>
           <a:prstGeom prst="rect">
@@ -11156,7 +11425,7 @@
         </p:nvSpPr>
         <p:spPr>
           <a:xfrm>
-            <a:off x="3246120" y="3291840"/>
+            <a:off x="3246120" y="3429000"/>
             <a:ext cx="2606040" cy="1188720"/>
           </a:xfrm>
           <a:prstGeom prst="rect">
@@ -11206,7 +11475,7 @@
         </p:nvSpPr>
         <p:spPr>
           <a:xfrm>
-            <a:off x="6035040" y="3291840"/>
+            <a:off x="6035040" y="3429000"/>
             <a:ext cx="2606040" cy="1188720"/>
           </a:xfrm>
           <a:prstGeom prst="rect">
@@ -11242,7 +11511,7 @@
                   <a:schemeClr val="tx1"/>
                 </a:solidFill>
               </a:rPr>
-              <a:t>12 C. elegans frames, 2,958 hand-marked nuclei, 4 nucleus detectors</a:t>
+              <a:t>12 C. elegans frames from 2 embryos, 2,958 hand-marked nuclei, 4 detectors</a:t>
             </a:r>
             <a:endParaRPr lang="en-US" sz="1500" dirty="0"/>
           </a:p>
@@ -11628,7 +11897,7 @@
                   <a:schemeClr val="tx1"/>
                 </a:solidFill>
               </a:rPr>
-              <a:t>Below ~3 blobs per nucleus, nuclei vanish</a:t>
+              <a:t>C. elegans: nuclei vanish below ~3 blobs each</a:t>
             </a:r>
             <a:endParaRPr lang="en-US" sz="2800" dirty="0"/>
           </a:p>
@@ -11751,7 +12020,7 @@
                   <a:schemeClr val="tx1"/>
                 </a:solidFill>
               </a:rPr>
-              <a:t>Nuclei kept drops below 90% at 1.1-3.1 blobs per nucleus, on all 12 frames</a:t>
+              <a:t>Under LoG, nuclei kept crosses 90% at 1.1–3.1 blobs per nucleus (all 12 frames)</a:t>
             </a:r>
             <a:endParaRPr lang="en-US" sz="1400" dirty="0"/>
           </a:p>
@@ -11850,7 +12119,7 @@
                   <a:schemeClr val="tx1"/>
                 </a:solidFill>
               </a:rPr>
-              <a:t>Barely moves over these budgets: at most 2.6 dB per frame</a:t>
+              <a:t>For budgets of 1,000+ blobs it moves at most 2.6 dB per frame</a:t>
             </a:r>
             <a:endParaRPr lang="en-US" sz="1400" dirty="0"/>
           </a:p>
@@ -11949,7 +12218,7 @@
                   <a:schemeClr val="tx1"/>
                 </a:solidFill>
               </a:rPr>
-              <a:t>Image quality cannot tell you when the blob budget is too small</a:t>
+              <a:t>Choosing the budget by PSNR can miss the cliff: check the nuclei</a:t>
             </a:r>
             <a:endParaRPr lang="en-US" sz="1400" dirty="0"/>
           </a:p>
@@ -12088,7 +12357,7 @@
           <a:p>
             <a:pPr algn="l" marL="342900" indent="-342900">
               <a:spcAft>
-                <a:spcPts val="1400"/>
+                <a:spcPts val="1200"/>
               </a:spcAft>
               <a:buSzPct val="100000"/>
               <a:buChar char="•"/>
@@ -12099,14 +12368,14 @@
                   <a:srgbClr val="E5E7EB"/>
                 </a:solidFill>
               </a:rPr>
-              <a:t>Shape, starting points, step size and a size cap each made the fit find more nuclei.</a:t>
+              <a:t>Stretched blobs, one start per nucleus and a size cap made our fits find more nuclei; a simple blob filter still ranks them better.</a:t>
             </a:r>
             <a:endParaRPr lang="en-US" sz="1700" dirty="0"/>
           </a:p>
           <a:p>
             <a:pPr algn="l" marL="342900" indent="-342900">
               <a:spcAft>
-                <a:spcPts val="1400"/>
+                <a:spcPts val="1200"/>
               </a:spcAft>
               <a:buSzPct val="100000"/>
               <a:buChar char="•"/>
@@ -12117,14 +12386,14 @@
                   <a:srgbClr val="E5E7EB"/>
                 </a:solidFill>
               </a:rPr>
-              <a:t>Blobs are good for looking, not for measuring: at the same file size a standard codec keeps nuclei as well or better.</a:t>
+              <a:t>At the same file size, the better format depends on the detector and the compression: blobs help 3D Cellpose below 300×, JPEG2000 wins beyond.</a:t>
             </a:r>
             <a:endParaRPr lang="en-US" sz="1700" dirty="0"/>
           </a:p>
           <a:p>
             <a:pPr algn="l" marL="342900" indent="-342900">
               <a:spcAft>
-                <a:spcPts val="1400"/>
+                <a:spcPts val="1200"/>
               </a:spcAft>
               <a:buSzPct val="100000"/>
               <a:buChar char="•"/>
@@ -12135,7 +12404,7 @@
                   <a:srgbClr val="E5E7EB"/>
                 </a:solidFill>
               </a:rPr>
-              <a:t>PSNR cannot choose the format: test with the analysis you will actually run.</a:t>
+              <a:t>Viewing and measuring need separate checks: PSNR cannot choose the format.</a:t>
             </a:r>
             <a:endParaRPr lang="en-US" sz="1700" dirty="0"/>
           </a:p>
@@ -12686,8 +12955,8 @@
         </p:nvSpPr>
         <p:spPr>
           <a:xfrm>
-            <a:off x="457200" y="1188720"/>
-            <a:ext cx="548640" cy="548640"/>
+            <a:off x="457200" y="1097280"/>
+            <a:ext cx="502920" cy="502920"/>
           </a:xfrm>
           <a:prstGeom prst="ellipse">
             <a:avLst/>
@@ -12711,8 +12980,8 @@
         </p:nvSpPr>
         <p:spPr>
           <a:xfrm>
-            <a:off x="457200" y="1188720"/>
-            <a:ext cx="548640" cy="548640"/>
+            <a:off x="457200" y="1097280"/>
+            <a:ext cx="502920" cy="502920"/>
           </a:xfrm>
           <a:prstGeom prst="rect">
             <a:avLst/>
@@ -12728,14 +12997,14 @@
               <a:buNone/>
             </a:pPr>
             <a:r>
-              <a:rPr lang="en-US" sz="2000" b="1" dirty="0">
+              <a:rPr lang="en-US" sz="1800" b="1" dirty="0">
                 <a:solidFill>
                   <a:schemeClr val="bg1"/>
                 </a:solidFill>
               </a:rPr>
               <a:t>1</a:t>
             </a:r>
-            <a:endParaRPr lang="en-US" sz="2000" dirty="0"/>
+            <a:endParaRPr lang="en-US" sz="1800" dirty="0"/>
           </a:p>
         </p:txBody>
       </p:sp>
@@ -12747,8 +13016,8 @@
         </p:nvSpPr>
         <p:spPr>
           <a:xfrm>
-            <a:off x="1234440" y="1143000"/>
-            <a:ext cx="7406640" cy="914400"/>
+            <a:off x="1188720" y="1051560"/>
+            <a:ext cx="7498080" cy="777240"/>
           </a:xfrm>
           <a:prstGeom prst="rect">
             <a:avLst/>
@@ -12764,28 +13033,28 @@
               <a:buNone/>
             </a:pPr>
             <a:r>
-              <a:rPr lang="en-US" sz="1700" b="1" dirty="0">
+              <a:rPr lang="en-US" sz="1600" b="1" dirty="0">
                 <a:solidFill>
                   <a:schemeClr val="tx1"/>
                 </a:solidFill>
               </a:rPr>
-              <a:t>Lossless and near-lossless</a:t>
-            </a:r>
-            <a:endParaRPr lang="en-US" sz="1700" dirty="0"/>
+              <a:t>Lossless storage</a:t>
+            </a:r>
+            <a:endParaRPr lang="en-US" sz="1600" dirty="0"/>
           </a:p>
           <a:p>
             <a:pPr indent="0" marL="0">
               <a:buNone/>
             </a:pPr>
             <a:r>
-              <a:rPr lang="en-US" sz="1700" dirty="0">
+              <a:rPr lang="en-US" sz="1600" dirty="0">
                 <a:solidFill>
                   <a:srgbClr val="3A3F4B"/>
                 </a:solidFill>
               </a:rPr>
-              <a:t>what labs actually store: exact, or errors kept below the camera noise</a:t>
-            </a:r>
-            <a:endParaRPr lang="en-US" sz="1700" dirty="0"/>
+              <a:t>what labs keep today: bit-exact; 4.2× with lossless JPEG-XL on one C. elegans frame</a:t>
+            </a:r>
+            <a:endParaRPr lang="en-US" sz="1600" dirty="0"/>
           </a:p>
         </p:txBody>
       </p:sp>
@@ -12797,8 +13066,8 @@
         </p:nvSpPr>
         <p:spPr>
           <a:xfrm>
-            <a:off x="457200" y="2286000"/>
-            <a:ext cx="548640" cy="548640"/>
+            <a:off x="457200" y="1965960"/>
+            <a:ext cx="502920" cy="502920"/>
           </a:xfrm>
           <a:prstGeom prst="ellipse">
             <a:avLst/>
@@ -12822,8 +13091,8 @@
         </p:nvSpPr>
         <p:spPr>
           <a:xfrm>
-            <a:off x="457200" y="2286000"/>
-            <a:ext cx="548640" cy="548640"/>
+            <a:off x="457200" y="1965960"/>
+            <a:ext cx="502920" cy="502920"/>
           </a:xfrm>
           <a:prstGeom prst="rect">
             <a:avLst/>
@@ -12839,14 +13108,14 @@
               <a:buNone/>
             </a:pPr>
             <a:r>
-              <a:rPr lang="en-US" sz="2000" b="1" dirty="0">
+              <a:rPr lang="en-US" sz="1800" b="1" dirty="0">
                 <a:solidFill>
                   <a:schemeClr val="bg1"/>
                 </a:solidFill>
               </a:rPr>
               <a:t>2</a:t>
             </a:r>
-            <a:endParaRPr lang="en-US" sz="2000" dirty="0"/>
+            <a:endParaRPr lang="en-US" sz="1800" dirty="0"/>
           </a:p>
         </p:txBody>
       </p:sp>
@@ -12858,8 +13127,8 @@
         </p:nvSpPr>
         <p:spPr>
           <a:xfrm>
-            <a:off x="1234440" y="2240280"/>
-            <a:ext cx="7406640" cy="914400"/>
+            <a:off x="1188720" y="1920240"/>
+            <a:ext cx="7498080" cy="777240"/>
           </a:xfrm>
           <a:prstGeom prst="rect">
             <a:avLst/>
@@ -12875,28 +13144,28 @@
               <a:buNone/>
             </a:pPr>
             <a:r>
-              <a:rPr lang="en-US" sz="1700" b="1" dirty="0">
+              <a:rPr lang="en-US" sz="1600" b="1" dirty="0">
                 <a:solidFill>
                   <a:schemeClr val="tx1"/>
                 </a:solidFill>
               </a:rPr>
-              <a:t>Video codecs</a:t>
-            </a:r>
-            <a:endParaRPr lang="en-US" sz="1700" dirty="0"/>
+              <a:t>Noise-bounded coding</a:t>
+            </a:r>
+            <a:endParaRPr lang="en-US" sz="1600" dirty="0"/>
           </a:p>
           <a:p>
             <a:pPr indent="0" marL="0">
               <a:buNone/>
             </a:pPr>
             <a:r>
-              <a:rPr lang="en-US" sz="1700" dirty="0">
+              <a:rPr lang="en-US" sz="1600" dirty="0">
                 <a:solidFill>
                   <a:srgbClr val="3A3F4B"/>
                 </a:solidFill>
               </a:rPr>
-              <a:t>use the similarity between neighbouring slices and time points</a:t>
-            </a:r>
-            <a:endParaRPr lang="en-US" sz="1700" dirty="0"/>
+              <a:t>one specific near-lossless method: every change kept below the camera noise</a:t>
+            </a:r>
+            <a:endParaRPr lang="en-US" sz="1600" dirty="0"/>
           </a:p>
         </p:txBody>
       </p:sp>
@@ -12908,8 +13177,8 @@
         </p:nvSpPr>
         <p:spPr>
           <a:xfrm>
-            <a:off x="457200" y="3383280"/>
-            <a:ext cx="548640" cy="548640"/>
+            <a:off x="457200" y="2834640"/>
+            <a:ext cx="502920" cy="502920"/>
           </a:xfrm>
           <a:prstGeom prst="ellipse">
             <a:avLst/>
@@ -12933,8 +13202,8 @@
         </p:nvSpPr>
         <p:spPr>
           <a:xfrm>
-            <a:off x="457200" y="3383280"/>
-            <a:ext cx="548640" cy="548640"/>
+            <a:off x="457200" y="2834640"/>
+            <a:ext cx="502920" cy="502920"/>
           </a:xfrm>
           <a:prstGeom prst="rect">
             <a:avLst/>
@@ -12950,14 +13219,14 @@
               <a:buNone/>
             </a:pPr>
             <a:r>
-              <a:rPr lang="en-US" sz="2000" b="1" dirty="0">
+              <a:rPr lang="en-US" sz="1800" b="1" dirty="0">
                 <a:solidFill>
                   <a:schemeClr val="bg1"/>
                 </a:solidFill>
               </a:rPr>
               <a:t>3</a:t>
             </a:r>
-            <a:endParaRPr lang="en-US" sz="2000" dirty="0"/>
+            <a:endParaRPr lang="en-US" sz="1800" dirty="0"/>
           </a:p>
         </p:txBody>
       </p:sp>
@@ -12969,8 +13238,8 @@
         </p:nvSpPr>
         <p:spPr>
           <a:xfrm>
-            <a:off x="1234440" y="3337560"/>
-            <a:ext cx="7406640" cy="914400"/>
+            <a:off x="1188720" y="2788920"/>
+            <a:ext cx="7498080" cy="777240"/>
           </a:xfrm>
           <a:prstGeom prst="rect">
             <a:avLst/>
@@ -12986,28 +13255,139 @@
               <a:buNone/>
             </a:pPr>
             <a:r>
-              <a:rPr lang="en-US" sz="1700" b="1" dirty="0">
+              <a:rPr lang="en-US" sz="1600" b="1" dirty="0">
                 <a:solidFill>
                   <a:schemeClr val="tx1"/>
                 </a:solidFill>
               </a:rPr>
-              <a:t>Judge by tracking</a:t>
-            </a:r>
-            <a:endParaRPr lang="en-US" sz="1700" dirty="0"/>
+              <a:t>Video codecs</a:t>
+            </a:r>
+            <a:endParaRPr lang="en-US" sz="1600" dirty="0"/>
           </a:p>
           <a:p>
             <a:pPr indent="0" marL="0">
               <a:buNone/>
             </a:pPr>
             <a:r>
-              <a:rPr lang="en-US" sz="1700" dirty="0">
+              <a:rPr lang="en-US" sz="1600" dirty="0">
+                <a:solidFill>
+                  <a:srgbClr val="3A3F4B"/>
+                </a:solidFill>
+              </a:rPr>
+              <a:t>use the similarity between neighbouring slices and time points</a:t>
+            </a:r>
+            <a:endParaRPr lang="en-US" sz="1600" dirty="0"/>
+          </a:p>
+        </p:txBody>
+      </p:sp>
+      <p:sp>
+        <p:nvSpPr>
+          <p:cNvPr id="12" name="num-3"/>
+          <p:cNvSpPr/>
+          <p:nvPr/>
+        </p:nvSpPr>
+        <p:spPr>
+          <a:xfrm>
+            <a:off x="457200" y="3703320"/>
+            <a:ext cx="502920" cy="502920"/>
+          </a:xfrm>
+          <a:prstGeom prst="ellipse">
+            <a:avLst/>
+          </a:prstGeom>
+          <a:solidFill>
+            <a:schemeClr val="accent1"/>
+          </a:solidFill>
+          <a:ln w="12700">
+            <a:solidFill>
+              <a:schemeClr val="accent1"/>
+            </a:solidFill>
+            <a:prstDash val="solid"/>
+          </a:ln>
+        </p:spPr>
+      </p:sp>
+      <p:sp>
+        <p:nvSpPr>
+          <p:cNvPr id="13" name="Text 11"/>
+          <p:cNvSpPr txBox="1"/>
+          <p:nvPr/>
+        </p:nvSpPr>
+        <p:spPr>
+          <a:xfrm>
+            <a:off x="457200" y="3703320"/>
+            <a:ext cx="502920" cy="502920"/>
+          </a:xfrm>
+          <a:prstGeom prst="rect">
+            <a:avLst/>
+          </a:prstGeom>
+          <a:noFill/>
+          <a:ln/>
+        </p:spPr>
+        <p:txBody>
+          <a:bodyPr wrap="square" lIns="0" tIns="0" rIns="0" bIns="0" rtlCol="0" anchor="ctr"/>
+          <a:lstStyle/>
+          <a:p>
+            <a:pPr algn="ctr" indent="0" marL="0">
+              <a:buNone/>
+            </a:pPr>
+            <a:r>
+              <a:rPr lang="en-US" sz="1800" b="1" dirty="0">
+                <a:solidFill>
+                  <a:schemeClr val="bg1"/>
+                </a:solidFill>
+              </a:rPr>
+              <a:t>4</a:t>
+            </a:r>
+            <a:endParaRPr lang="en-US" sz="1800" dirty="0"/>
+          </a:p>
+        </p:txBody>
+      </p:sp>
+      <p:sp>
+        <p:nvSpPr>
+          <p:cNvPr id="14" name="Text 12"/>
+          <p:cNvSpPr txBox="1"/>
+          <p:nvPr/>
+        </p:nvSpPr>
+        <p:spPr>
+          <a:xfrm>
+            <a:off x="1188720" y="3657600"/>
+            <a:ext cx="7498080" cy="777240"/>
+          </a:xfrm>
+          <a:prstGeom prst="rect">
+            <a:avLst/>
+          </a:prstGeom>
+          <a:noFill/>
+          <a:ln/>
+        </p:spPr>
+        <p:txBody>
+          <a:bodyPr wrap="square" lIns="0" tIns="0" rIns="0" bIns="0" rtlCol="0" anchor="t"/>
+          <a:lstStyle/>
+          <a:p>
+            <a:pPr indent="0" marL="0">
+              <a:buNone/>
+            </a:pPr>
+            <a:r>
+              <a:rPr lang="en-US" sz="1600" b="1" dirty="0">
+                <a:solidFill>
+                  <a:schemeClr val="tx1"/>
+                </a:solidFill>
+              </a:rPr>
+              <a:t>Judge by tracking</a:t>
+            </a:r>
+            <a:endParaRPr lang="en-US" sz="1600" dirty="0"/>
+          </a:p>
+          <a:p>
+            <a:pPr indent="0" marL="0">
+              <a:buNone/>
+            </a:pPr>
+            <a:r>
+              <a:rPr lang="en-US" sz="1600" dirty="0">
                 <a:solidFill>
                   <a:srgbClr val="3A3F4B"/>
                 </a:solidFill>
               </a:rPr>
               <a:t>measure with the Cell Tracking Challenge scores, not image quality</a:t>
             </a:r>
-            <a:endParaRPr lang="en-US" sz="1700" dirty="0"/>
+            <a:endParaRPr lang="en-US" sz="1600" dirty="0"/>
           </a:p>
         </p:txBody>
       </p:sp>
@@ -14715,7 +15095,7 @@
                   <a:schemeClr val="tx1"/>
                 </a:solidFill>
               </a:rPr>
-              <a:t>47.9 dB, almost perfect. The usual splatting renderer scored −7.1 dB</a:t>
+              <a:t>Same fit, 15-blob phantom: 31.7 dB at voxels, −7.1 dB via the splatting renderer. Final fit: 47.9 dB</a:t>
             </a:r>
             <a:endParaRPr lang="en-US" sz="1400" dirty="0"/>
           </a:p>

</xml_diff>

<commit_message>
Narrow mechanism, ranking and recipe-table wording
- Step 8: widening is an end-of-fit association (nearest Gaussian, no tracked identities,
  scored before the matcher fix), supported by the cap result; no trajectory claim.
  Appendix no longer says the trajectory results are unused.
- LoG vs fits: better in the top 100 (16-18 vs 14), level in the top 200 (22 vs 22.7);
  Figure 6 caption, abstract, intro, summary table, discussion, deck validation/conclusion.
- Recipe table (slide 14, report Table 6): separate comparisons under the stated settings,
  not a chain; cell-count row is a budget increase 301 -> 1,804, not a rule comparison.
- Cellpose 2D vs 3D: supports an explanation involving processing geometry, does not
  isolate the cause (deck notes, report, paper, CLAIMS.md C8).

Co-Authored-By: Claude Opus 5.5 <noreply@anthropic.com>
</commit_message>
<xml_diff>
--- a/Gaussian_Blobs_Microscopy_v3.pptx
+++ b/Gaussian_Blobs_Microscopy_v3.pptx
@@ -126,14 +126,14 @@
   <p:extLst>
     <p:ext uri="{521415D9-36F7-43E2-AB2F-B90AF26B5E84}">
       <p14:sectionLst xmlns:p14="http://schemas.microsoft.com/office/powerpoint/2010/main">
-        <p14:section name="Problem and data" id="{f0cb90bf-5370-dd24-6bd1-a6a499ffaea1}">
+        <p14:section name="Problem and data" id="{5983f150-4517-19ae-46d9-458fe5fd8afb}">
           <p14:sldIdLst>
             <p14:sldId id="256"/>
             <p14:sldId id="257"/>
             <p14:sldId id="258"/>
           </p14:sldIdLst>
         </p14:section>
-        <p14:section name="Simple setup and changes" id="{955a83b3-7c75-e644-26e6-77322385f96f}">
+        <p14:section name="Simple setup and changes" id="{6872d267-8e90-7de7-9c17-14ef7ee0ea64}">
           <p14:sldIdLst>
             <p14:sldId id="259"/>
             <p14:sldId id="260"/>
@@ -147,20 +147,20 @@
             <p14:sldId id="268"/>
           </p14:sldIdLst>
         </p14:section>
-        <p14:section name="Results and validation" id="{d2428e7c-28ba-f775-847e-5c4575903008}">
+        <p14:section name="Results and validation" id="{186691af-cd23-7d81-0408-1f0c9b9c073e}">
           <p14:sldIdLst>
             <p14:sldId id="269"/>
             <p14:sldId id="270"/>
           </p14:sldIdLst>
         </p14:section>
-        <p14:section name="State of the art" id="{46c815d5-1349-f594-b4e2-df17eb9553c8}">
+        <p14:section name="State of the art" id="{8fcbf522-fa52-f205-3a87-9e9a879bba53}">
           <p14:sldIdLst>
             <p14:sldId id="271"/>
             <p14:sldId id="272"/>
             <p14:sldId id="273"/>
           </p14:sldIdLst>
         </p14:section>
-        <p14:section name="Conclusion" id="{272ed676-6756-d3dc-c3e9-13391b3178cc}">
+        <p14:section name="Conclusion" id="{54ecf05a-c125-d6eb-39da-2a283ca0ac1b}">
           <p14:sldIdLst>
             <p14:sldId id="274"/>
             <p14:sldId id="275"/>
@@ -3041,13 +3041,14 @@
             <a:r>
               <a:rPr lang="en-US" dirty="0"/>
               <a:t>SAY:
-We then asked which nuclei are still lost. They are the faint ones, and when we followed their blobs during fitting, the blobs did not fade; they spread out, about 30 percent wider than for nuclei we kept, until there was no peak left to detect. So we capped the width of nucleus blobs. Over four regions, faint nuclei found went from 13 of 31 to 19 of 31, and image quality changed by only 0.01 dB. Honestly: one region got worse, and on the Drosophila data the cap changed nothing.
+We then asked which nuclei are still lost. They are the faint ones. At the end of fitting, the blob nearest to each lost faint nucleus was not dimmer than for the nuclei we kept, but about 30 percent wider, and a wide blob leaves only a flat peak for the detector. So we capped the width of nucleus blobs. With the cap, faint nuclei found went from 13 of 31 to 19 of 31 over four regions, and image quality changed by only 0.01 dB. Honestly: this is one seed, one region got worse, and on the Drosophila data the cap changed nothing. Also, we compared the blobs at the end of fitting; we did not track them through fitting, so the widening is an association that the cap result supports, not a demonstrated cause.
 TERMS ON THIS SLIDE:
 - Faint nucleus: one whose brightness above the surroundings is in the lower half.
 - Size cap: an upper limit on a blob's size, applied only to the blobs that started on nuclei.
 - Region: one 64 x 128 x 128 crop of the Tribolium frame.
 IF ASKED:
-- Is +6 nuclei significant? It is one seed and 4 regions, so treat it as promising, not settled. The result survived a scoring-bug fix (it was +7 before).</a:t>
+- Is +6 nuclei significant? It is one seed and 4 regions, so treat it as promising, not settled. The result survived a scoring-bug fix (it was +7 before).
+- Did you watch the blobs widen? No. We compared the blob nearest to each nucleus at the end of fitting, not blobs tracked over time. That width comparison was also scored before the scoring-bug fix and could not be redone.</a:t>
             </a:r>
             <a:endParaRPr lang="en-US" dirty="0"/>
           </a:p>
@@ -3136,7 +3137,7 @@
             <a:r>
               <a:rPr lang="en-US" dirty="0"/>
               <a:t>SAY:
-Here are all eight changes side by side, four by Akim and four by us, each compared with the version just before it. I want to be clear that these were measured one at a time, on different data and with different numbers of repeats, so you cannot add them up into one overall improvement. Together they turn a fit that merely looks right into one where the nuclei are found much more reliably.
+Here are all eight changes side by side, four by Akim and four by us. I want to be clear that these are separate comparisons, each under the settings on its own slide, not a chain where every row builds on the one above. They used different data, budgets and numbers of repeats, so you cannot add them up into one overall improvement. One row needs care: the cell-count row shows F1 rising as the budget grows from 301 to 1,804 blobs; it does not show that choosing the budget from the cell count beats another way of choosing it. Together, the changes turn a fit that merely looks right into one where the nuclei are found much more reliably.
 TERMS ON THIS SLIDE:
 - Naive / simple setup: round blobs with random starting positions, default step size, no cap.
 IF ASKED:
@@ -3237,6 +3238,7 @@
 IF ASKED:
 - How noisy is 14 vs 10? One nucleus is 3.4% of 29; we only call a difference real if it is about 3 nuclei and has the same sign in all seeds (mean of 3 seeds here).
 - Why 16-18? 16 with LoG scales fixed in advance (1.5-3 micrometres); 18 with a single 2-micrometre scale chosen after seeing results.
+- And in the top 200? There the best fit (uniform sampling, 22.7) and LoG (22) are level, within one nucleus. The filter is clearly better only in the top 100.
 - Are fits repeatable? Our own fits: seed spread at most 0.13 dB (Step 5). Luxar, used on the next slides: three repeated fits of one frame differed by at most 2.1-3.7 percentage points of nuclei kept, depending on the detector.</a:t>
             </a:r>
             <a:endParaRPr lang="en-US" dirty="0"/>
@@ -3424,7 +3426,7 @@
             <a:r>
               <a:rPr lang="en-US" dirty="0"/>
               <a:t>SAY:
-The result. Bars above zero mean the blobs kept more nuclei than JPEG2000 at the same file size; below zero, JPEG2000 kept more. Up to about 300 times compression the answer depends on the detector: Cellpose in 3D mode finds 3.5 points more nuclei in the blob version, the classical watershed and Cellpose in 2D mode find more in JPEG2000, and the simple blob detector LoG shows no consistent difference. Beyond 300 times, every detector prefers JPEG2000 by 17 to 23 points. Meanwhile PSNR says JPEG2000 is better on every single frame, so PSNR alone could not have told you which format a given analysis needs. The same Cellpose network changing sides between 2D and 3D mode shows the problem comes from processing slice by slice.
+The result. Bars above zero mean the blobs kept more nuclei than JPEG2000 at the same file size; below zero, JPEG2000 kept more. Up to about 300 times compression the answer depends on the detector: Cellpose in 3D mode finds 3.5 points more nuclei in the blob version, the classical watershed and Cellpose in 2D mode find more in JPEG2000, and the simple blob detector LoG shows no consistent difference. Beyond 300 times, every detector prefers JPEG2000 by 17 to 23 points. Meanwhile PSNR says JPEG2000 is better on every single frame, so PSNR alone could not have told you which format a given analysis needs. The same Cellpose network changing sides between 2D and 3D mode supports an explanation involving processing geometry: slice by slice versus the whole volume. Switching modes shows that the behaviour differs; it does not isolate the exact cause.
 TERMS ON THIS SLIDE:
 - LoG (Laplacian of Gaussian): a classic blob detector that responds to bright round spots of a given size.
 - Watershed: a classical segmentation that separates touching bright regions, like water filling valleys.
@@ -3433,6 +3435,7 @@
 - Statistics: each frame counts once; Wilcoxon signed-rank tests over the 12 frames, Holm-corrected for 8 tests. Everything except LoG below 300x is significant (Holm-corrected p ≤ 0.01). The 12 frames come from only 2 embryos, so they are not 12 independent animals.
 IF ASKED:
 - Is LoG +1.3 real? No: 8 of 12 frames, p = 0.11; it comes from one embryo only.
+- Is slice-by-slice processing proven to be the cause? No. Same network, same weights, different behaviour: so the penalty is not a fixed property of the learned model. But 3D mode also changes how predictions are combined and cleaned up, so the mode switch does not isolate geometry as the cause.
 - Why frames and not single comparisons? An earlier draft averaged all matched pairs, with bootstrap intervals per pair. Pairs from one frame are not independent, so the final analysis averages per frame first and tests across frames; the numbers here are that final analysis, the same as in the paper.
 - Why does JPEG2000 win at high compression? Below about 3 blobs per nucleus, blob fits lose whole nuclei; wavelet compression degrades gradually.</a:t>
             </a:r>
@@ -3619,7 +3622,7 @@
             <a:r>
               <a:rPr lang="en-US" dirty="0"/>
               <a:t>SAY:
-Three take-aways. One: our step-by-step changes made blob fits find nuclei more reliably, but on hand-marked nuclei a simple blob filter still ranks them better. Two: compared with the state of the art at the same file size, there is no single winner. Below 300 times, the blobs help 3D Cellpose and hurt the watershed and 2D Cellpose; beyond 300 times JPEG2000 keeps more nuclei for every detector. Three: a format that looks good is not automatically good for measuring, and the usual image-quality number cannot decide this; you have to test with the analysis you plan to run.
+Three take-aways. One: our step-by-step changes made blob fits find nuclei more reliably, but on hand-marked nuclei a simple blob filter still ranks them better among the top 100 detections, and as well among the top 200. Two: compared with the state of the art at the same file size, there is no single winner. Below 300 times, the blobs help 3D Cellpose and hurt the watershed and 2D Cellpose; beyond 300 times JPEG2000 keeps more nuclei for every detector. Three: a format that looks good is not automatically good for measuring, and the usual image-quality number cannot decide this; you have to test with the analysis you plan to run.
 TERMS ON THIS SLIDE:
 - Codec: a compression method (coder-decoder).
 IF ASKED:
@@ -4495,6 +4498,7 @@
 - Under-trained: the fit stopped before it had finished improving.
 IF ASKED:
 - Are the 230 cells ground truth? No, they come from a detector with fixed settings; the hand-marked checks come later (validation slide and the state-of-the-art test).
+- Does this show that the cell-count rule is a good way to pick the budget? No. F1 rose because the budget grew sixfold, from 301 to 1,804 blobs. The rule was never compared with another way of choosing the budget.
 - Why does PSNR fall with more blobs? The number of fitting steps was fixed at 3,000; more blobs need more steps. We later saw the same confound in our own experiments.</a:t>
             </a:r>
             <a:endParaRPr lang="en-US" dirty="0"/>
@@ -7059,7 +7063,7 @@
                   <a:schemeClr val="tx1"/>
                 </a:solidFill>
               </a:rPr>
-              <a:t>Lost faint nuclei had blobs ~30% wider, spread out until no peak was left</a:t>
+              <a:t>At the end of fitting, blobs at lost faint nuclei were ~30% wider than at kept ones</a:t>
             </a:r>
             <a:endParaRPr lang="en-US" sz="1400" dirty="0"/>
           </a:p>
@@ -8687,7 +8691,7 @@
                           <a:ea typeface="Calibri" pitchFamily="34" charset="-122"/>
                           <a:cs typeface="Calibri" pitchFamily="34" charset="-120"/>
                         </a:rPr>
-                        <a:t>Blobs set from cell count</a:t>
+                        <a:t>More blobs, in cell-count units</a:t>
                       </a:r>
                       <a:endParaRPr lang="en-US" sz="1400" dirty="0">
                         <a:latin typeface="Calibri" charset="0"/>
@@ -8823,7 +8827,7 @@
                           <a:ea typeface="Calibri" pitchFamily="34" charset="-122"/>
                           <a:cs typeface="Calibri" pitchFamily="34" charset="-120"/>
                         </a:rPr>
-                        <a:t>cell matching F1</a:t>
+                        <a:t>cell F1, 301 → 1,804 blobs</a:t>
                       </a:r>
                       <a:endParaRPr lang="en-US" sz="1400" dirty="0">
                         <a:latin typeface="Calibri" charset="0"/>
@@ -10413,7 +10417,7 @@
                   <a:schemeClr val="tx2"/>
                 </a:solidFill>
               </a:rPr>
-              <a:t>Each change measured on its own, against the version before it; the numbers are not added together.</a:t>
+              <a:t>Separate comparisons under the stated settings; the numbers are not added together.</a:t>
             </a:r>
             <a:endParaRPr lang="en-US" sz="1400" dirty="0"/>
           </a:p>
@@ -10863,7 +10867,7 @@
                   <a:schemeClr val="tx2"/>
                 </a:solidFill>
               </a:rPr>
-              <a:t>Fitting ranks nuclei better than brightness, but not better than a simple blob filter. With all 457 candidates the raw detector finds 26 of 29.</a:t>
+              <a:t>In the top 100, fitting ranks nuclei better than brightness but not better than a simple blob filter. With all 457 candidates the raw detector finds 26 of 29.</a:t>
             </a:r>
             <a:endParaRPr lang="en-US" sz="1500" dirty="0"/>
           </a:p>
@@ -12368,7 +12372,7 @@
                   <a:srgbClr val="E5E7EB"/>
                 </a:solidFill>
               </a:rPr>
-              <a:t>Stretched blobs, one start per nucleus and a size cap made our fits find more nuclei; a simple blob filter still ranks them better.</a:t>
+              <a:t>Stretched blobs, one start per nucleus and a size cap made our fits find more nuclei; in the top 100, a simple blob filter still ranks them better.</a:t>
             </a:r>
             <a:endParaRPr lang="en-US" sz="1700" dirty="0"/>
           </a:p>

</xml_diff>